<commit_message>
docs: cover loop prevention in mentor ppt
</commit_message>
<xml_diff>
--- a/docs/presentations/p2p-mesh-mentor-2026-06-15.pptx
+++ b/docs/presentations/p2p-mesh-mentor-2026-06-15.pptx
@@ -4636,7 +4636,7 @@
               </a:defRPr>
             </a:pPr>
             <a:r>
-              <a:t>重复消息复用上次 ACK</a:t>
+              <a:t>重复 user-message 去重并复用上次 ACK</a:t>
             </a:r>
           </a:p>
           <a:p>
@@ -4833,7 +4833,7 @@
               </a:defRPr>
             </a:pPr>
             <a:r>
-              <a:t>不自动执行远端指令</a:t>
+              <a:t>防循环：ACK 不再作为普通消息转发</a:t>
             </a:r>
           </a:p>
           <a:p>

</xml_diff>

<commit_message>
docs: improve mentor ppt layout readability
</commit_message>
<xml_diff>
--- a/docs/presentations/p2p-mesh-mentor-2026-06-15.pptx
+++ b/docs/presentations/p2p-mesh-mentor-2026-06-15.pptx
@@ -3115,8 +3115,8 @@
         </p:nvSpPr>
         <p:spPr>
           <a:xfrm>
-            <a:off x="502920" y="292608"/>
-            <a:ext cx="7772400" cy="502920"/>
+            <a:off x="685800" y="292608"/>
+            <a:ext cx="8549640" cy="566928"/>
           </a:xfrm>
           <a:prstGeom prst="rect">
             <a:avLst/>
@@ -3124,13 +3124,13 @@
           <a:noFill/>
         </p:spPr>
         <p:txBody>
-          <a:bodyPr wrap="none">
+          <a:bodyPr wrap="square" lIns="54864" rIns="54864" tIns="18288" bIns="18288">
             <a:spAutoFit/>
           </a:bodyPr>
           <a:lstStyle/>
           <a:p>
             <a:pPr>
-              <a:defRPr sz="3000" b="1">
+              <a:defRPr sz="2700" b="1">
                 <a:solidFill>
                   <a:srgbClr val="0F172A"/>
                 </a:solidFill>
@@ -3151,8 +3151,8 @@
         </p:nvSpPr>
         <p:spPr>
           <a:xfrm>
-            <a:off x="530352" y="822960"/>
-            <a:ext cx="8046720" cy="292608"/>
+            <a:off x="713232" y="841248"/>
+            <a:ext cx="8321040" cy="310896"/>
           </a:xfrm>
           <a:prstGeom prst="rect">
             <a:avLst/>
@@ -3160,7 +3160,7 @@
           <a:noFill/>
         </p:spPr>
         <p:txBody>
-          <a:bodyPr wrap="none">
+          <a:bodyPr wrap="square" lIns="36576" rIns="36576">
             <a:spAutoFit/>
           </a:bodyPr>
           <a:lstStyle/>
@@ -3332,8 +3332,8 @@
         </p:nvSpPr>
         <p:spPr>
           <a:xfrm>
-            <a:off x="932688" y="1764792"/>
-            <a:ext cx="2359152" cy="274320"/>
+            <a:off x="932688" y="1746504"/>
+            <a:ext cx="2359152" cy="310896"/>
           </a:xfrm>
           <a:prstGeom prst="rect">
             <a:avLst/>
@@ -3341,7 +3341,7 @@
           <a:noFill/>
         </p:spPr>
         <p:txBody>
-          <a:bodyPr wrap="none">
+          <a:bodyPr wrap="square" lIns="27432" rIns="27432" tIns="18288" bIns="18288">
             <a:spAutoFit/>
           </a:bodyPr>
           <a:lstStyle/>
@@ -3369,7 +3369,7 @@
         <p:spPr>
           <a:xfrm>
             <a:off x="932688" y="2130552"/>
-            <a:ext cx="2359152" cy="548640"/>
+            <a:ext cx="2359152" cy="566928"/>
           </a:xfrm>
           <a:prstGeom prst="rect">
             <a:avLst/>
@@ -3377,7 +3377,7 @@
           <a:noFill/>
         </p:spPr>
         <p:txBody>
-          <a:bodyPr wrap="square">
+          <a:bodyPr wrap="square" lIns="27432" rIns="27432" tIns="18288" bIns="18288">
             <a:spAutoFit/>
           </a:bodyPr>
           <a:lstStyle/>
@@ -3497,8 +3497,8 @@
         </p:nvSpPr>
         <p:spPr>
           <a:xfrm>
-            <a:off x="4773168" y="1764792"/>
-            <a:ext cx="2359152" cy="274320"/>
+            <a:off x="4773168" y="1746504"/>
+            <a:ext cx="2359152" cy="310896"/>
           </a:xfrm>
           <a:prstGeom prst="rect">
             <a:avLst/>
@@ -3506,7 +3506,7 @@
           <a:noFill/>
         </p:spPr>
         <p:txBody>
-          <a:bodyPr wrap="none">
+          <a:bodyPr wrap="square" lIns="27432" rIns="27432" tIns="18288" bIns="18288">
             <a:spAutoFit/>
           </a:bodyPr>
           <a:lstStyle/>
@@ -3534,7 +3534,7 @@
         <p:spPr>
           <a:xfrm>
             <a:off x="4773168" y="2130552"/>
-            <a:ext cx="2359152" cy="548640"/>
+            <a:ext cx="2359152" cy="566928"/>
           </a:xfrm>
           <a:prstGeom prst="rect">
             <a:avLst/>
@@ -3542,7 +3542,7 @@
           <a:noFill/>
         </p:spPr>
         <p:txBody>
-          <a:bodyPr wrap="square">
+          <a:bodyPr wrap="square" lIns="27432" rIns="27432" tIns="18288" bIns="18288">
             <a:spAutoFit/>
           </a:bodyPr>
           <a:lstStyle/>
@@ -3662,8 +3662,8 @@
         </p:nvSpPr>
         <p:spPr>
           <a:xfrm>
-            <a:off x="8613648" y="1764792"/>
-            <a:ext cx="2359152" cy="274320"/>
+            <a:off x="8613648" y="1746504"/>
+            <a:ext cx="2359152" cy="310896"/>
           </a:xfrm>
           <a:prstGeom prst="rect">
             <a:avLst/>
@@ -3671,7 +3671,7 @@
           <a:noFill/>
         </p:spPr>
         <p:txBody>
-          <a:bodyPr wrap="none">
+          <a:bodyPr wrap="square" lIns="27432" rIns="27432" tIns="18288" bIns="18288">
             <a:spAutoFit/>
           </a:bodyPr>
           <a:lstStyle/>
@@ -3699,7 +3699,7 @@
         <p:spPr>
           <a:xfrm>
             <a:off x="8613648" y="2130552"/>
-            <a:ext cx="2359152" cy="548640"/>
+            <a:ext cx="2359152" cy="566928"/>
           </a:xfrm>
           <a:prstGeom prst="rect">
             <a:avLst/>
@@ -3707,7 +3707,7 @@
           <a:noFill/>
         </p:spPr>
         <p:txBody>
-          <a:bodyPr wrap="square">
+          <a:bodyPr wrap="square" lIns="27432" rIns="27432" tIns="18288" bIns="18288">
             <a:spAutoFit/>
           </a:bodyPr>
           <a:lstStyle/>
@@ -3816,7 +3816,7 @@
           <a:noFill/>
         </p:spPr>
         <p:txBody>
-          <a:bodyPr wrap="none">
+          <a:bodyPr wrap="square" lIns="73152" rIns="73152" tIns="27432" bIns="27432">
             <a:spAutoFit/>
           </a:bodyPr>
           <a:lstStyle/>
@@ -3924,8 +3924,8 @@
         </p:nvSpPr>
         <p:spPr>
           <a:xfrm>
-            <a:off x="502920" y="292608"/>
-            <a:ext cx="7772400" cy="502920"/>
+            <a:off x="685800" y="292608"/>
+            <a:ext cx="8549640" cy="566928"/>
           </a:xfrm>
           <a:prstGeom prst="rect">
             <a:avLst/>
@@ -3933,13 +3933,13 @@
           <a:noFill/>
         </p:spPr>
         <p:txBody>
-          <a:bodyPr wrap="none">
+          <a:bodyPr wrap="square" lIns="54864" rIns="54864" tIns="18288" bIns="18288">
             <a:spAutoFit/>
           </a:bodyPr>
           <a:lstStyle/>
           <a:p>
             <a:pPr>
-              <a:defRPr sz="3000" b="1">
+              <a:defRPr sz="2900" b="1">
                 <a:solidFill>
                   <a:srgbClr val="0F172A"/>
                 </a:solidFill>
@@ -4015,8 +4015,8 @@
         </p:nvSpPr>
         <p:spPr>
           <a:xfrm>
-            <a:off x="777240" y="1325880"/>
-            <a:ext cx="6766560" cy="4389120"/>
+            <a:off x="868680" y="1325880"/>
+            <a:ext cx="6217920" cy="4389120"/>
           </a:xfrm>
           <a:prstGeom prst="rect">
             <a:avLst/>
@@ -4024,7 +4024,7 @@
           <a:noFill/>
         </p:spPr>
         <p:txBody>
-          <a:bodyPr wrap="none">
+          <a:bodyPr wrap="square" lIns="73152" rIns="73152" tIns="27432" bIns="27432">
             <a:spAutoFit/>
           </a:bodyPr>
           <a:lstStyle/>
@@ -4228,8 +4228,8 @@
         </p:nvSpPr>
         <p:spPr>
           <a:xfrm>
-            <a:off x="7882128" y="1490472"/>
-            <a:ext cx="3273552" cy="274320"/>
+            <a:off x="7882128" y="1472184"/>
+            <a:ext cx="3273552" cy="402336"/>
           </a:xfrm>
           <a:prstGeom prst="rect">
             <a:avLst/>
@@ -4237,13 +4237,13 @@
           <a:noFill/>
         </p:spPr>
         <p:txBody>
-          <a:bodyPr wrap="none">
+          <a:bodyPr wrap="square" lIns="27432" rIns="27432" tIns="18288" bIns="18288">
             <a:spAutoFit/>
           </a:bodyPr>
           <a:lstStyle/>
           <a:p>
             <a:pPr>
-              <a:defRPr sz="1600" b="1">
+              <a:defRPr sz="1200" b="1">
                 <a:solidFill>
                   <a:srgbClr val="0F172A"/>
                 </a:solidFill>
@@ -4264,8 +4264,8 @@
         </p:nvSpPr>
         <p:spPr>
           <a:xfrm>
-            <a:off x="7882128" y="1856231"/>
-            <a:ext cx="3273552" cy="1508760"/>
+            <a:off x="7882128" y="1892807"/>
+            <a:ext cx="3273552" cy="1490472"/>
           </a:xfrm>
           <a:prstGeom prst="rect">
             <a:avLst/>
@@ -4273,7 +4273,7 @@
           <a:noFill/>
         </p:spPr>
         <p:txBody>
-          <a:bodyPr wrap="square">
+          <a:bodyPr wrap="square" lIns="27432" rIns="27432" tIns="18288" bIns="18288">
             <a:spAutoFit/>
           </a:bodyPr>
           <a:lstStyle/>
@@ -4377,8 +4377,8 @@
         </p:nvSpPr>
         <p:spPr>
           <a:xfrm>
-            <a:off x="502920" y="292608"/>
-            <a:ext cx="7772400" cy="502920"/>
+            <a:off x="685800" y="292608"/>
+            <a:ext cx="8549640" cy="566928"/>
           </a:xfrm>
           <a:prstGeom prst="rect">
             <a:avLst/>
@@ -4386,13 +4386,13 @@
           <a:noFill/>
         </p:spPr>
         <p:txBody>
-          <a:bodyPr wrap="none">
+          <a:bodyPr wrap="square" lIns="54864" rIns="54864" tIns="18288" bIns="18288">
             <a:spAutoFit/>
           </a:bodyPr>
           <a:lstStyle/>
           <a:p>
             <a:pPr>
-              <a:defRPr sz="3000" b="1">
+              <a:defRPr sz="2900" b="1">
                 <a:solidFill>
                   <a:srgbClr val="0F172A"/>
                 </a:solidFill>
@@ -4558,8 +4558,8 @@
         </p:nvSpPr>
         <p:spPr>
           <a:xfrm>
-            <a:off x="978408" y="1399032"/>
-            <a:ext cx="4599432" cy="274320"/>
+            <a:off x="978408" y="1380744"/>
+            <a:ext cx="4599432" cy="310896"/>
           </a:xfrm>
           <a:prstGeom prst="rect">
             <a:avLst/>
@@ -4567,7 +4567,7 @@
           <a:noFill/>
         </p:spPr>
         <p:txBody>
-          <a:bodyPr wrap="none">
+          <a:bodyPr wrap="square" lIns="27432" rIns="27432" tIns="18288" bIns="18288">
             <a:spAutoFit/>
           </a:bodyPr>
           <a:lstStyle/>
@@ -4595,7 +4595,7 @@
         <p:spPr>
           <a:xfrm>
             <a:off x="978408" y="1764792"/>
-            <a:ext cx="4599432" cy="2880360"/>
+            <a:ext cx="4599432" cy="2898648"/>
           </a:xfrm>
           <a:prstGeom prst="rect">
             <a:avLst/>
@@ -4603,7 +4603,7 @@
           <a:noFill/>
         </p:spPr>
         <p:txBody>
-          <a:bodyPr wrap="square">
+          <a:bodyPr wrap="square" lIns="27432" rIns="27432" tIns="18288" bIns="18288">
             <a:spAutoFit/>
           </a:bodyPr>
           <a:lstStyle/>
@@ -4755,8 +4755,8 @@
         </p:nvSpPr>
         <p:spPr>
           <a:xfrm>
-            <a:off x="6647688" y="1399032"/>
-            <a:ext cx="4599432" cy="274320"/>
+            <a:off x="6647688" y="1380744"/>
+            <a:ext cx="4599432" cy="310896"/>
           </a:xfrm>
           <a:prstGeom prst="rect">
             <a:avLst/>
@@ -4764,7 +4764,7 @@
           <a:noFill/>
         </p:spPr>
         <p:txBody>
-          <a:bodyPr wrap="none">
+          <a:bodyPr wrap="square" lIns="27432" rIns="27432" tIns="18288" bIns="18288">
             <a:spAutoFit/>
           </a:bodyPr>
           <a:lstStyle/>
@@ -4792,7 +4792,7 @@
         <p:spPr>
           <a:xfrm>
             <a:off x="6647688" y="1764792"/>
-            <a:ext cx="4599432" cy="2880360"/>
+            <a:ext cx="4599432" cy="2898648"/>
           </a:xfrm>
           <a:prstGeom prst="rect">
             <a:avLst/>
@@ -4800,7 +4800,7 @@
           <a:noFill/>
         </p:spPr>
         <p:txBody>
-          <a:bodyPr wrap="square">
+          <a:bodyPr wrap="square" lIns="27432" rIns="27432" tIns="18288" bIns="18288">
             <a:spAutoFit/>
           </a:bodyPr>
           <a:lstStyle/>
@@ -4924,8 +4924,8 @@
         </p:nvSpPr>
         <p:spPr>
           <a:xfrm>
-            <a:off x="502920" y="292608"/>
-            <a:ext cx="7772400" cy="502920"/>
+            <a:off x="685800" y="292608"/>
+            <a:ext cx="8549640" cy="566928"/>
           </a:xfrm>
           <a:prstGeom prst="rect">
             <a:avLst/>
@@ -4933,13 +4933,13 @@
           <a:noFill/>
         </p:spPr>
         <p:txBody>
-          <a:bodyPr wrap="none">
+          <a:bodyPr wrap="square" lIns="54864" rIns="54864" tIns="18288" bIns="18288">
             <a:spAutoFit/>
           </a:bodyPr>
           <a:lstStyle/>
           <a:p>
             <a:pPr>
-              <a:defRPr sz="3000" b="1">
+              <a:defRPr sz="2900" b="1">
                 <a:solidFill>
                   <a:srgbClr val="0F172A"/>
                 </a:solidFill>
@@ -5105,8 +5105,8 @@
         </p:nvSpPr>
         <p:spPr>
           <a:xfrm>
-            <a:off x="978408" y="1581912"/>
-            <a:ext cx="2862072" cy="274320"/>
+            <a:off x="978408" y="1563624"/>
+            <a:ext cx="2862072" cy="310896"/>
           </a:xfrm>
           <a:prstGeom prst="rect">
             <a:avLst/>
@@ -5114,7 +5114,7 @@
           <a:noFill/>
         </p:spPr>
         <p:txBody>
-          <a:bodyPr wrap="none">
+          <a:bodyPr wrap="square" lIns="27432" rIns="27432" tIns="18288" bIns="18288">
             <a:spAutoFit/>
           </a:bodyPr>
           <a:lstStyle/>
@@ -5142,7 +5142,7 @@
         <p:spPr>
           <a:xfrm>
             <a:off x="978408" y="1947672"/>
-            <a:ext cx="2862072" cy="1463040"/>
+            <a:ext cx="2862072" cy="1481328"/>
           </a:xfrm>
           <a:prstGeom prst="rect">
             <a:avLst/>
@@ -5150,7 +5150,7 @@
           <a:noFill/>
         </p:spPr>
         <p:txBody>
-          <a:bodyPr wrap="square">
+          <a:bodyPr wrap="square" lIns="27432" rIns="27432" tIns="18288" bIns="18288">
             <a:spAutoFit/>
           </a:bodyPr>
           <a:lstStyle/>
@@ -5286,8 +5286,8 @@
         </p:nvSpPr>
         <p:spPr>
           <a:xfrm>
-            <a:off x="4681728" y="1581912"/>
-            <a:ext cx="2862072" cy="274320"/>
+            <a:off x="4681728" y="1563624"/>
+            <a:ext cx="2862072" cy="310896"/>
           </a:xfrm>
           <a:prstGeom prst="rect">
             <a:avLst/>
@@ -5295,7 +5295,7 @@
           <a:noFill/>
         </p:spPr>
         <p:txBody>
-          <a:bodyPr wrap="none">
+          <a:bodyPr wrap="square" lIns="27432" rIns="27432" tIns="18288" bIns="18288">
             <a:spAutoFit/>
           </a:bodyPr>
           <a:lstStyle/>
@@ -5323,7 +5323,7 @@
         <p:spPr>
           <a:xfrm>
             <a:off x="4681728" y="1947672"/>
-            <a:ext cx="2862072" cy="1463040"/>
+            <a:ext cx="2862072" cy="1481328"/>
           </a:xfrm>
           <a:prstGeom prst="rect">
             <a:avLst/>
@@ -5331,7 +5331,7 @@
           <a:noFill/>
         </p:spPr>
         <p:txBody>
-          <a:bodyPr wrap="square">
+          <a:bodyPr wrap="square" lIns="27432" rIns="27432" tIns="18288" bIns="18288">
             <a:spAutoFit/>
           </a:bodyPr>
           <a:lstStyle/>
@@ -5467,8 +5467,8 @@
         </p:nvSpPr>
         <p:spPr>
           <a:xfrm>
-            <a:off x="8385048" y="1581912"/>
-            <a:ext cx="2862072" cy="274320"/>
+            <a:off x="8385048" y="1563624"/>
+            <a:ext cx="2862072" cy="310896"/>
           </a:xfrm>
           <a:prstGeom prst="rect">
             <a:avLst/>
@@ -5476,7 +5476,7 @@
           <a:noFill/>
         </p:spPr>
         <p:txBody>
-          <a:bodyPr wrap="none">
+          <a:bodyPr wrap="square" lIns="27432" rIns="27432" tIns="18288" bIns="18288">
             <a:spAutoFit/>
           </a:bodyPr>
           <a:lstStyle/>
@@ -5504,7 +5504,7 @@
         <p:spPr>
           <a:xfrm>
             <a:off x="8385048" y="1947672"/>
-            <a:ext cx="2862072" cy="1463040"/>
+            <a:ext cx="2862072" cy="1481328"/>
           </a:xfrm>
           <a:prstGeom prst="rect">
             <a:avLst/>
@@ -5512,7 +5512,7 @@
           <a:noFill/>
         </p:spPr>
         <p:txBody>
-          <a:bodyPr wrap="square">
+          <a:bodyPr wrap="square" lIns="27432" rIns="27432" tIns="18288" bIns="18288">
             <a:spAutoFit/>
           </a:bodyPr>
           <a:lstStyle/>
@@ -5567,7 +5567,7 @@
           <a:noFill/>
         </p:spPr>
         <p:txBody>
-          <a:bodyPr wrap="none">
+          <a:bodyPr wrap="square" lIns="73152" rIns="73152" tIns="27432" bIns="27432">
             <a:spAutoFit/>
           </a:bodyPr>
           <a:lstStyle/>
@@ -5659,8 +5659,8 @@
         </p:nvSpPr>
         <p:spPr>
           <a:xfrm>
-            <a:off x="502920" y="292608"/>
-            <a:ext cx="7772400" cy="502920"/>
+            <a:off x="685800" y="292608"/>
+            <a:ext cx="8549640" cy="566928"/>
           </a:xfrm>
           <a:prstGeom prst="rect">
             <a:avLst/>
@@ -5668,13 +5668,13 @@
           <a:noFill/>
         </p:spPr>
         <p:txBody>
-          <a:bodyPr wrap="none">
+          <a:bodyPr wrap="square" lIns="54864" rIns="54864" tIns="18288" bIns="18288">
             <a:spAutoFit/>
           </a:bodyPr>
           <a:lstStyle/>
           <a:p>
             <a:pPr>
-              <a:defRPr sz="3000" b="1">
+              <a:defRPr sz="2700" b="1">
                 <a:solidFill>
                   <a:srgbClr val="0F172A"/>
                 </a:solidFill>
@@ -5750,8 +5750,8 @@
         </p:nvSpPr>
         <p:spPr>
           <a:xfrm>
-            <a:off x="777240" y="1325880"/>
-            <a:ext cx="6766560" cy="4389120"/>
+            <a:off x="868680" y="1325880"/>
+            <a:ext cx="6217920" cy="4389120"/>
           </a:xfrm>
           <a:prstGeom prst="rect">
             <a:avLst/>
@@ -5759,7 +5759,7 @@
           <a:noFill/>
         </p:spPr>
         <p:txBody>
-          <a:bodyPr wrap="none">
+          <a:bodyPr wrap="square" lIns="73152" rIns="73152" tIns="27432" bIns="27432">
             <a:spAutoFit/>
           </a:bodyPr>
           <a:lstStyle/>
@@ -5947,8 +5947,8 @@
         </p:nvSpPr>
         <p:spPr>
           <a:xfrm>
-            <a:off x="8202168" y="1581912"/>
-            <a:ext cx="1353312" cy="274320"/>
+            <a:off x="8202168" y="1563624"/>
+            <a:ext cx="1353312" cy="310896"/>
           </a:xfrm>
           <a:prstGeom prst="rect">
             <a:avLst/>
@@ -5956,7 +5956,7 @@
           <a:noFill/>
         </p:spPr>
         <p:txBody>
-          <a:bodyPr wrap="none">
+          <a:bodyPr wrap="square" lIns="27432" rIns="27432" tIns="18288" bIns="18288">
             <a:spAutoFit/>
           </a:bodyPr>
           <a:lstStyle/>
@@ -5984,7 +5984,7 @@
         <p:spPr>
           <a:xfrm>
             <a:off x="8202168" y="1947672"/>
-            <a:ext cx="1353312" cy="457200"/>
+            <a:ext cx="1353312" cy="475488"/>
           </a:xfrm>
           <a:prstGeom prst="rect">
             <a:avLst/>
@@ -5992,7 +5992,7 @@
           <a:noFill/>
         </p:spPr>
         <p:txBody>
-          <a:bodyPr wrap="square">
+          <a:bodyPr wrap="square" lIns="27432" rIns="27432" tIns="18288" bIns="18288">
             <a:spAutoFit/>
           </a:bodyPr>
           <a:lstStyle/>
@@ -6128,8 +6128,8 @@
         </p:nvSpPr>
         <p:spPr>
           <a:xfrm>
-            <a:off x="10030968" y="1581912"/>
-            <a:ext cx="1353312" cy="274320"/>
+            <a:off x="10030968" y="1563624"/>
+            <a:ext cx="1353312" cy="310896"/>
           </a:xfrm>
           <a:prstGeom prst="rect">
             <a:avLst/>
@@ -6137,7 +6137,7 @@
           <a:noFill/>
         </p:spPr>
         <p:txBody>
-          <a:bodyPr wrap="none">
+          <a:bodyPr wrap="square" lIns="27432" rIns="27432" tIns="18288" bIns="18288">
             <a:spAutoFit/>
           </a:bodyPr>
           <a:lstStyle/>
@@ -6165,7 +6165,7 @@
         <p:spPr>
           <a:xfrm>
             <a:off x="10030968" y="1947672"/>
-            <a:ext cx="1353312" cy="457200"/>
+            <a:ext cx="1353312" cy="475488"/>
           </a:xfrm>
           <a:prstGeom prst="rect">
             <a:avLst/>
@@ -6173,7 +6173,7 @@
           <a:noFill/>
         </p:spPr>
         <p:txBody>
-          <a:bodyPr wrap="square">
+          <a:bodyPr wrap="square" lIns="27432" rIns="27432" tIns="18288" bIns="18288">
             <a:spAutoFit/>
           </a:bodyPr>
           <a:lstStyle/>
@@ -6245,8 +6245,8 @@
         </p:nvSpPr>
         <p:spPr>
           <a:xfrm>
-            <a:off x="502920" y="292608"/>
-            <a:ext cx="7772400" cy="502920"/>
+            <a:off x="685800" y="292608"/>
+            <a:ext cx="8549640" cy="566928"/>
           </a:xfrm>
           <a:prstGeom prst="rect">
             <a:avLst/>
@@ -6254,13 +6254,13 @@
           <a:noFill/>
         </p:spPr>
         <p:txBody>
-          <a:bodyPr wrap="none">
+          <a:bodyPr wrap="square" lIns="54864" rIns="54864" tIns="18288" bIns="18288">
             <a:spAutoFit/>
           </a:bodyPr>
           <a:lstStyle/>
           <a:p>
             <a:pPr>
-              <a:defRPr sz="3000" b="1">
+              <a:defRPr sz="2900" b="1">
                 <a:solidFill>
                   <a:srgbClr val="0F172A"/>
                 </a:solidFill>
@@ -6426,8 +6426,8 @@
         </p:nvSpPr>
         <p:spPr>
           <a:xfrm>
-            <a:off x="612648" y="2039112"/>
-            <a:ext cx="850392" cy="274320"/>
+            <a:off x="612648" y="2020824"/>
+            <a:ext cx="850392" cy="402336"/>
           </a:xfrm>
           <a:prstGeom prst="rect">
             <a:avLst/>
@@ -6435,13 +6435,13 @@
           <a:noFill/>
         </p:spPr>
         <p:txBody>
-          <a:bodyPr wrap="none">
+          <a:bodyPr wrap="square" lIns="27432" rIns="27432" tIns="18288" bIns="18288">
             <a:spAutoFit/>
           </a:bodyPr>
           <a:lstStyle/>
           <a:p>
             <a:pPr>
-              <a:defRPr sz="1600" b="1">
+              <a:defRPr sz="1200" b="1">
                 <a:solidFill>
                   <a:srgbClr val="0F172A"/>
                 </a:solidFill>
@@ -6462,8 +6462,8 @@
         </p:nvSpPr>
         <p:spPr>
           <a:xfrm>
-            <a:off x="612648" y="2404872"/>
-            <a:ext cx="850392" cy="274320"/>
+            <a:off x="612648" y="2441448"/>
+            <a:ext cx="850392" cy="256031"/>
           </a:xfrm>
           <a:prstGeom prst="rect">
             <a:avLst/>
@@ -6471,7 +6471,7 @@
           <a:noFill/>
         </p:spPr>
         <p:txBody>
-          <a:bodyPr wrap="square">
+          <a:bodyPr wrap="square" lIns="27432" rIns="27432" tIns="18288" bIns="18288">
             <a:spAutoFit/>
           </a:bodyPr>
           <a:lstStyle/>
@@ -6626,8 +6626,8 @@
         </p:nvSpPr>
         <p:spPr>
           <a:xfrm>
-            <a:off x="2240280" y="2039112"/>
-            <a:ext cx="850392" cy="274320"/>
+            <a:off x="2240280" y="2020824"/>
+            <a:ext cx="850392" cy="402336"/>
           </a:xfrm>
           <a:prstGeom prst="rect">
             <a:avLst/>
@@ -6635,13 +6635,13 @@
           <a:noFill/>
         </p:spPr>
         <p:txBody>
-          <a:bodyPr wrap="none">
+          <a:bodyPr wrap="square" lIns="27432" rIns="27432" tIns="18288" bIns="18288">
             <a:spAutoFit/>
           </a:bodyPr>
           <a:lstStyle/>
           <a:p>
             <a:pPr>
-              <a:defRPr sz="1600" b="1">
+              <a:defRPr sz="1200" b="1">
                 <a:solidFill>
                   <a:srgbClr val="0F172A"/>
                 </a:solidFill>
@@ -6662,8 +6662,8 @@
         </p:nvSpPr>
         <p:spPr>
           <a:xfrm>
-            <a:off x="2240280" y="2404872"/>
-            <a:ext cx="850392" cy="274320"/>
+            <a:off x="2240280" y="2441448"/>
+            <a:ext cx="850392" cy="256031"/>
           </a:xfrm>
           <a:prstGeom prst="rect">
             <a:avLst/>
@@ -6671,7 +6671,7 @@
           <a:noFill/>
         </p:spPr>
         <p:txBody>
-          <a:bodyPr wrap="square">
+          <a:bodyPr wrap="square" lIns="27432" rIns="27432" tIns="18288" bIns="18288">
             <a:spAutoFit/>
           </a:bodyPr>
           <a:lstStyle/>
@@ -6826,8 +6826,8 @@
         </p:nvSpPr>
         <p:spPr>
           <a:xfrm>
-            <a:off x="3867911" y="2039112"/>
-            <a:ext cx="850392" cy="274320"/>
+            <a:off x="3867911" y="2020824"/>
+            <a:ext cx="850392" cy="402336"/>
           </a:xfrm>
           <a:prstGeom prst="rect">
             <a:avLst/>
@@ -6835,13 +6835,13 @@
           <a:noFill/>
         </p:spPr>
         <p:txBody>
-          <a:bodyPr wrap="none">
+          <a:bodyPr wrap="square" lIns="27432" rIns="27432" tIns="18288" bIns="18288">
             <a:spAutoFit/>
           </a:bodyPr>
           <a:lstStyle/>
           <a:p>
             <a:pPr>
-              <a:defRPr sz="1600" b="1">
+              <a:defRPr sz="1200" b="1">
                 <a:solidFill>
                   <a:srgbClr val="0F172A"/>
                 </a:solidFill>
@@ -6862,8 +6862,8 @@
         </p:nvSpPr>
         <p:spPr>
           <a:xfrm>
-            <a:off x="3867911" y="2404872"/>
-            <a:ext cx="850392" cy="274320"/>
+            <a:off x="3867911" y="2441448"/>
+            <a:ext cx="850392" cy="256031"/>
           </a:xfrm>
           <a:prstGeom prst="rect">
             <a:avLst/>
@@ -6871,7 +6871,7 @@
           <a:noFill/>
         </p:spPr>
         <p:txBody>
-          <a:bodyPr wrap="square">
+          <a:bodyPr wrap="square" lIns="27432" rIns="27432" tIns="18288" bIns="18288">
             <a:spAutoFit/>
           </a:bodyPr>
           <a:lstStyle/>
@@ -7026,8 +7026,8 @@
         </p:nvSpPr>
         <p:spPr>
           <a:xfrm>
-            <a:off x="5495544" y="2039112"/>
-            <a:ext cx="850392" cy="274320"/>
+            <a:off x="5495544" y="2020824"/>
+            <a:ext cx="850392" cy="402336"/>
           </a:xfrm>
           <a:prstGeom prst="rect">
             <a:avLst/>
@@ -7035,13 +7035,13 @@
           <a:noFill/>
         </p:spPr>
         <p:txBody>
-          <a:bodyPr wrap="none">
+          <a:bodyPr wrap="square" lIns="27432" rIns="27432" tIns="18288" bIns="18288">
             <a:spAutoFit/>
           </a:bodyPr>
           <a:lstStyle/>
           <a:p>
             <a:pPr>
-              <a:defRPr sz="1600" b="1">
+              <a:defRPr sz="1200" b="1">
                 <a:solidFill>
                   <a:srgbClr val="0F172A"/>
                 </a:solidFill>
@@ -7062,8 +7062,8 @@
         </p:nvSpPr>
         <p:spPr>
           <a:xfrm>
-            <a:off x="5495544" y="2404872"/>
-            <a:ext cx="850392" cy="274320"/>
+            <a:off x="5495544" y="2441448"/>
+            <a:ext cx="850392" cy="256031"/>
           </a:xfrm>
           <a:prstGeom prst="rect">
             <a:avLst/>
@@ -7071,7 +7071,7 @@
           <a:noFill/>
         </p:spPr>
         <p:txBody>
-          <a:bodyPr wrap="square">
+          <a:bodyPr wrap="square" lIns="27432" rIns="27432" tIns="18288" bIns="18288">
             <a:spAutoFit/>
           </a:bodyPr>
           <a:lstStyle/>
@@ -7226,8 +7226,8 @@
         </p:nvSpPr>
         <p:spPr>
           <a:xfrm>
-            <a:off x="7123176" y="2039112"/>
-            <a:ext cx="850392" cy="274320"/>
+            <a:off x="7123176" y="2020824"/>
+            <a:ext cx="850392" cy="402336"/>
           </a:xfrm>
           <a:prstGeom prst="rect">
             <a:avLst/>
@@ -7235,13 +7235,13 @@
           <a:noFill/>
         </p:spPr>
         <p:txBody>
-          <a:bodyPr wrap="none">
+          <a:bodyPr wrap="square" lIns="27432" rIns="27432" tIns="18288" bIns="18288">
             <a:spAutoFit/>
           </a:bodyPr>
           <a:lstStyle/>
           <a:p>
             <a:pPr>
-              <a:defRPr sz="1600" b="1">
+              <a:defRPr sz="1200" b="1">
                 <a:solidFill>
                   <a:srgbClr val="0F172A"/>
                 </a:solidFill>
@@ -7262,8 +7262,8 @@
         </p:nvSpPr>
         <p:spPr>
           <a:xfrm>
-            <a:off x="7123176" y="2404872"/>
-            <a:ext cx="850392" cy="274320"/>
+            <a:off x="7123176" y="2441448"/>
+            <a:ext cx="850392" cy="256031"/>
           </a:xfrm>
           <a:prstGeom prst="rect">
             <a:avLst/>
@@ -7271,7 +7271,7 @@
           <a:noFill/>
         </p:spPr>
         <p:txBody>
-          <a:bodyPr wrap="square">
+          <a:bodyPr wrap="square" lIns="27432" rIns="27432" tIns="18288" bIns="18288">
             <a:spAutoFit/>
           </a:bodyPr>
           <a:lstStyle/>
@@ -7426,8 +7426,8 @@
         </p:nvSpPr>
         <p:spPr>
           <a:xfrm>
-            <a:off x="8750808" y="2039112"/>
-            <a:ext cx="850392" cy="274320"/>
+            <a:off x="8750808" y="2020824"/>
+            <a:ext cx="850392" cy="402336"/>
           </a:xfrm>
           <a:prstGeom prst="rect">
             <a:avLst/>
@@ -7435,13 +7435,13 @@
           <a:noFill/>
         </p:spPr>
         <p:txBody>
-          <a:bodyPr wrap="none">
+          <a:bodyPr wrap="square" lIns="27432" rIns="27432" tIns="18288" bIns="18288">
             <a:spAutoFit/>
           </a:bodyPr>
           <a:lstStyle/>
           <a:p>
             <a:pPr>
-              <a:defRPr sz="1600" b="1">
+              <a:defRPr sz="1200" b="1">
                 <a:solidFill>
                   <a:srgbClr val="0F172A"/>
                 </a:solidFill>
@@ -7462,8 +7462,8 @@
         </p:nvSpPr>
         <p:spPr>
           <a:xfrm>
-            <a:off x="8750808" y="2404872"/>
-            <a:ext cx="850392" cy="274320"/>
+            <a:off x="8750808" y="2441448"/>
+            <a:ext cx="850392" cy="256031"/>
           </a:xfrm>
           <a:prstGeom prst="rect">
             <a:avLst/>
@@ -7471,7 +7471,7 @@
           <a:noFill/>
         </p:spPr>
         <p:txBody>
-          <a:bodyPr wrap="square">
+          <a:bodyPr wrap="square" lIns="27432" rIns="27432" tIns="18288" bIns="18288">
             <a:spAutoFit/>
           </a:bodyPr>
           <a:lstStyle/>
@@ -7626,8 +7626,8 @@
         </p:nvSpPr>
         <p:spPr>
           <a:xfrm>
-            <a:off x="10378440" y="2039112"/>
-            <a:ext cx="850392" cy="274320"/>
+            <a:off x="10378440" y="2020824"/>
+            <a:ext cx="850392" cy="402336"/>
           </a:xfrm>
           <a:prstGeom prst="rect">
             <a:avLst/>
@@ -7635,13 +7635,13 @@
           <a:noFill/>
         </p:spPr>
         <p:txBody>
-          <a:bodyPr wrap="none">
+          <a:bodyPr wrap="square" lIns="27432" rIns="27432" tIns="18288" bIns="18288">
             <a:spAutoFit/>
           </a:bodyPr>
           <a:lstStyle/>
           <a:p>
             <a:pPr>
-              <a:defRPr sz="1600" b="1">
+              <a:defRPr sz="1200" b="1">
                 <a:solidFill>
                   <a:srgbClr val="0F172A"/>
                 </a:solidFill>
@@ -7662,8 +7662,8 @@
         </p:nvSpPr>
         <p:spPr>
           <a:xfrm>
-            <a:off x="10378440" y="2404872"/>
-            <a:ext cx="850392" cy="274320"/>
+            <a:off x="10378440" y="2441448"/>
+            <a:ext cx="850392" cy="256031"/>
           </a:xfrm>
           <a:prstGeom prst="rect">
             <a:avLst/>
@@ -7671,7 +7671,7 @@
           <a:noFill/>
         </p:spPr>
         <p:txBody>
-          <a:bodyPr wrap="square">
+          <a:bodyPr wrap="square" lIns="27432" rIns="27432" tIns="18288" bIns="18288">
             <a:spAutoFit/>
           </a:bodyPr>
           <a:lstStyle/>
@@ -7800,7 +7800,7 @@
           <a:noFill/>
         </p:spPr>
         <p:txBody>
-          <a:bodyPr wrap="none">
+          <a:bodyPr wrap="square" lIns="73152" rIns="73152" tIns="27432" bIns="27432">
             <a:spAutoFit/>
           </a:bodyPr>
           <a:lstStyle/>
@@ -7892,8 +7892,8 @@
         </p:nvSpPr>
         <p:spPr>
           <a:xfrm>
-            <a:off x="502920" y="292608"/>
-            <a:ext cx="7772400" cy="502920"/>
+            <a:off x="685800" y="292608"/>
+            <a:ext cx="8549640" cy="566928"/>
           </a:xfrm>
           <a:prstGeom prst="rect">
             <a:avLst/>
@@ -7901,13 +7901,13 @@
           <a:noFill/>
         </p:spPr>
         <p:txBody>
-          <a:bodyPr wrap="none">
+          <a:bodyPr wrap="square" lIns="54864" rIns="54864" tIns="18288" bIns="18288">
             <a:spAutoFit/>
           </a:bodyPr>
           <a:lstStyle/>
           <a:p>
             <a:pPr>
-              <a:defRPr sz="3000" b="1">
+              <a:defRPr sz="2900" b="1">
                 <a:solidFill>
                   <a:srgbClr val="0F172A"/>
                 </a:solidFill>
@@ -7983,8 +7983,8 @@
         </p:nvSpPr>
         <p:spPr>
           <a:xfrm>
-            <a:off x="777240" y="1325880"/>
-            <a:ext cx="6766560" cy="4389120"/>
+            <a:off x="868680" y="1325880"/>
+            <a:ext cx="6217920" cy="4389120"/>
           </a:xfrm>
           <a:prstGeom prst="rect">
             <a:avLst/>
@@ -7992,7 +7992,7 @@
           <a:noFill/>
         </p:spPr>
         <p:txBody>
-          <a:bodyPr wrap="none">
+          <a:bodyPr wrap="square" lIns="73152" rIns="73152" tIns="27432" bIns="27432">
             <a:spAutoFit/>
           </a:bodyPr>
           <a:lstStyle/>
@@ -8025,7 +8025,23 @@
               </a:defRPr>
             </a:pPr>
             <a:r>
-              <a:t>Agent 主路径调用 p2p_send_instance_message({ instanceId, message })。</a:t>
+              <a:t>Agent 主路径调用实例发送工具。</a:t>
+            </a:r>
+          </a:p>
+          <a:p>
+            <a:pPr>
+              <a:spcAft>
+                <a:spcPts val="800"/>
+              </a:spcAft>
+              <a:defRPr sz="1900">
+                <a:solidFill>
+                  <a:srgbClr val="0F172A"/>
+                </a:solidFill>
+                <a:latin typeface="Aptos"/>
+              </a:defRPr>
+            </a:pPr>
+            <a:r>
+              <a:t>工具参数：p2p_send_instance_message({ instanceId, message })。</a:t>
             </a:r>
           </a:p>
           <a:p>
@@ -8196,8 +8212,8 @@
         </p:nvSpPr>
         <p:spPr>
           <a:xfrm>
-            <a:off x="7836408" y="1490472"/>
-            <a:ext cx="3364991" cy="274320"/>
+            <a:off x="7836408" y="1472184"/>
+            <a:ext cx="3364991" cy="310896"/>
           </a:xfrm>
           <a:prstGeom prst="rect">
             <a:avLst/>
@@ -8205,7 +8221,7 @@
           <a:noFill/>
         </p:spPr>
         <p:txBody>
-          <a:bodyPr wrap="none">
+          <a:bodyPr wrap="square" lIns="27432" rIns="27432" tIns="18288" bIns="18288">
             <a:spAutoFit/>
           </a:bodyPr>
           <a:lstStyle/>
@@ -8233,7 +8249,7 @@
         <p:spPr>
           <a:xfrm>
             <a:off x="7836408" y="1856231"/>
-            <a:ext cx="3364991" cy="320040"/>
+            <a:ext cx="3364991" cy="338328"/>
           </a:xfrm>
           <a:prstGeom prst="rect">
             <a:avLst/>
@@ -8241,7 +8257,7 @@
           <a:noFill/>
         </p:spPr>
         <p:txBody>
-          <a:bodyPr wrap="square">
+          <a:bodyPr wrap="square" lIns="27432" rIns="27432" tIns="18288" bIns="18288">
             <a:spAutoFit/>
           </a:bodyPr>
           <a:lstStyle/>
@@ -8361,8 +8377,8 @@
         </p:nvSpPr>
         <p:spPr>
           <a:xfrm>
-            <a:off x="7836408" y="2907792"/>
-            <a:ext cx="3364991" cy="274320"/>
+            <a:off x="7836408" y="2889504"/>
+            <a:ext cx="3364991" cy="310896"/>
           </a:xfrm>
           <a:prstGeom prst="rect">
             <a:avLst/>
@@ -8370,7 +8386,7 @@
           <a:noFill/>
         </p:spPr>
         <p:txBody>
-          <a:bodyPr wrap="none">
+          <a:bodyPr wrap="square" lIns="27432" rIns="27432" tIns="18288" bIns="18288">
             <a:spAutoFit/>
           </a:bodyPr>
           <a:lstStyle/>
@@ -8398,7 +8414,7 @@
         <p:spPr>
           <a:xfrm>
             <a:off x="7836408" y="3273552"/>
-            <a:ext cx="3364991" cy="548640"/>
+            <a:ext cx="3364991" cy="566928"/>
           </a:xfrm>
           <a:prstGeom prst="rect">
             <a:avLst/>
@@ -8406,7 +8422,7 @@
           <a:noFill/>
         </p:spPr>
         <p:txBody>
-          <a:bodyPr wrap="square">
+          <a:bodyPr wrap="square" lIns="27432" rIns="27432" tIns="18288" bIns="18288">
             <a:spAutoFit/>
           </a:bodyPr>
           <a:lstStyle/>
@@ -8513,8 +8529,8 @@
         </p:nvSpPr>
         <p:spPr>
           <a:xfrm>
-            <a:off x="502920" y="292608"/>
-            <a:ext cx="7772400" cy="502920"/>
+            <a:off x="685800" y="292608"/>
+            <a:ext cx="8549640" cy="566928"/>
           </a:xfrm>
           <a:prstGeom prst="rect">
             <a:avLst/>
@@ -8522,13 +8538,13 @@
           <a:noFill/>
         </p:spPr>
         <p:txBody>
-          <a:bodyPr wrap="none">
+          <a:bodyPr wrap="square" lIns="54864" rIns="54864" tIns="18288" bIns="18288">
             <a:spAutoFit/>
           </a:bodyPr>
           <a:lstStyle/>
           <a:p>
             <a:pPr>
-              <a:defRPr sz="3000" b="1">
+              <a:defRPr sz="2900" b="1">
                 <a:solidFill>
                   <a:srgbClr val="0F172A"/>
                 </a:solidFill>
@@ -8694,8 +8710,8 @@
         </p:nvSpPr>
         <p:spPr>
           <a:xfrm>
-            <a:off x="932688" y="1490472"/>
-            <a:ext cx="2359152" cy="274320"/>
+            <a:off x="932688" y="1472184"/>
+            <a:ext cx="2359152" cy="402336"/>
           </a:xfrm>
           <a:prstGeom prst="rect">
             <a:avLst/>
@@ -8703,13 +8719,13 @@
           <a:noFill/>
         </p:spPr>
         <p:txBody>
-          <a:bodyPr wrap="none">
+          <a:bodyPr wrap="square" lIns="27432" rIns="27432" tIns="18288" bIns="18288">
             <a:spAutoFit/>
           </a:bodyPr>
           <a:lstStyle/>
           <a:p>
             <a:pPr>
-              <a:defRPr sz="1600" b="1">
+              <a:defRPr sz="1200" b="1">
                 <a:solidFill>
                   <a:srgbClr val="0F172A"/>
                 </a:solidFill>
@@ -8730,8 +8746,8 @@
         </p:nvSpPr>
         <p:spPr>
           <a:xfrm>
-            <a:off x="932688" y="1856231"/>
-            <a:ext cx="2359152" cy="457200"/>
+            <a:off x="932688" y="1892807"/>
+            <a:ext cx="2359152" cy="438912"/>
           </a:xfrm>
           <a:prstGeom prst="rect">
             <a:avLst/>
@@ -8739,7 +8755,7 @@
           <a:noFill/>
         </p:spPr>
         <p:txBody>
-          <a:bodyPr wrap="square">
+          <a:bodyPr wrap="square" lIns="27432" rIns="27432" tIns="18288" bIns="18288">
             <a:spAutoFit/>
           </a:bodyPr>
           <a:lstStyle/>
@@ -8859,8 +8875,8 @@
         </p:nvSpPr>
         <p:spPr>
           <a:xfrm>
-            <a:off x="4773168" y="1490472"/>
-            <a:ext cx="2359152" cy="274320"/>
+            <a:off x="4773168" y="1472184"/>
+            <a:ext cx="2359152" cy="310896"/>
           </a:xfrm>
           <a:prstGeom prst="rect">
             <a:avLst/>
@@ -8868,7 +8884,7 @@
           <a:noFill/>
         </p:spPr>
         <p:txBody>
-          <a:bodyPr wrap="none">
+          <a:bodyPr wrap="square" lIns="27432" rIns="27432" tIns="18288" bIns="18288">
             <a:spAutoFit/>
           </a:bodyPr>
           <a:lstStyle/>
@@ -8896,7 +8912,7 @@
         <p:spPr>
           <a:xfrm>
             <a:off x="4773168" y="1856231"/>
-            <a:ext cx="2359152" cy="457200"/>
+            <a:ext cx="2359152" cy="475488"/>
           </a:xfrm>
           <a:prstGeom prst="rect">
             <a:avLst/>
@@ -8904,7 +8920,7 @@
           <a:noFill/>
         </p:spPr>
         <p:txBody>
-          <a:bodyPr wrap="square">
+          <a:bodyPr wrap="square" lIns="27432" rIns="27432" tIns="18288" bIns="18288">
             <a:spAutoFit/>
           </a:bodyPr>
           <a:lstStyle/>
@@ -9024,8 +9040,8 @@
         </p:nvSpPr>
         <p:spPr>
           <a:xfrm>
-            <a:off x="8613648" y="1490472"/>
-            <a:ext cx="2359152" cy="274320"/>
+            <a:off x="8613648" y="1472184"/>
+            <a:ext cx="2359152" cy="310896"/>
           </a:xfrm>
           <a:prstGeom prst="rect">
             <a:avLst/>
@@ -9033,7 +9049,7 @@
           <a:noFill/>
         </p:spPr>
         <p:txBody>
-          <a:bodyPr wrap="none">
+          <a:bodyPr wrap="square" lIns="27432" rIns="27432" tIns="18288" bIns="18288">
             <a:spAutoFit/>
           </a:bodyPr>
           <a:lstStyle/>
@@ -9061,7 +9077,7 @@
         <p:spPr>
           <a:xfrm>
             <a:off x="8613648" y="1856231"/>
-            <a:ext cx="2359152" cy="457200"/>
+            <a:ext cx="2359152" cy="475488"/>
           </a:xfrm>
           <a:prstGeom prst="rect">
             <a:avLst/>
@@ -9069,7 +9085,7 @@
           <a:noFill/>
         </p:spPr>
         <p:txBody>
-          <a:bodyPr wrap="square">
+          <a:bodyPr wrap="square" lIns="27432" rIns="27432" tIns="18288" bIns="18288">
             <a:spAutoFit/>
           </a:bodyPr>
           <a:lstStyle/>
@@ -9178,7 +9194,7 @@
           <a:noFill/>
         </p:spPr>
         <p:txBody>
-          <a:bodyPr wrap="none">
+          <a:bodyPr wrap="square" lIns="73152" rIns="73152" tIns="27432" bIns="27432">
             <a:spAutoFit/>
           </a:bodyPr>
           <a:lstStyle/>
@@ -9302,8 +9318,8 @@
         </p:nvSpPr>
         <p:spPr>
           <a:xfrm>
-            <a:off x="502920" y="292608"/>
-            <a:ext cx="7772400" cy="502920"/>
+            <a:off x="685800" y="292608"/>
+            <a:ext cx="8549640" cy="566928"/>
           </a:xfrm>
           <a:prstGeom prst="rect">
             <a:avLst/>
@@ -9311,13 +9327,13 @@
           <a:noFill/>
         </p:spPr>
         <p:txBody>
-          <a:bodyPr wrap="none">
+          <a:bodyPr wrap="square" lIns="54864" rIns="54864" tIns="18288" bIns="18288">
             <a:spAutoFit/>
           </a:bodyPr>
           <a:lstStyle/>
           <a:p>
             <a:pPr>
-              <a:defRPr sz="3000" b="1">
+              <a:defRPr sz="2900" b="1">
                 <a:solidFill>
                   <a:srgbClr val="0F172A"/>
                 </a:solidFill>
@@ -9483,8 +9499,8 @@
         </p:nvSpPr>
         <p:spPr>
           <a:xfrm>
-            <a:off x="886968" y="1581912"/>
-            <a:ext cx="3044952" cy="274320"/>
+            <a:off x="886968" y="1563624"/>
+            <a:ext cx="3044952" cy="402336"/>
           </a:xfrm>
           <a:prstGeom prst="rect">
             <a:avLst/>
@@ -9492,13 +9508,13 @@
           <a:noFill/>
         </p:spPr>
         <p:txBody>
-          <a:bodyPr wrap="none">
+          <a:bodyPr wrap="square" lIns="27432" rIns="27432" tIns="18288" bIns="18288">
             <a:spAutoFit/>
           </a:bodyPr>
           <a:lstStyle/>
           <a:p>
             <a:pPr>
-              <a:defRPr sz="1600" b="1">
+              <a:defRPr sz="1200" b="1">
                 <a:solidFill>
                   <a:srgbClr val="0F172A"/>
                 </a:solidFill>
@@ -9519,8 +9535,8 @@
         </p:nvSpPr>
         <p:spPr>
           <a:xfrm>
-            <a:off x="886968" y="1947672"/>
-            <a:ext cx="3044952" cy="2194560"/>
+            <a:off x="886968" y="1984248"/>
+            <a:ext cx="3044952" cy="2176272"/>
           </a:xfrm>
           <a:prstGeom prst="rect">
             <a:avLst/>
@@ -9528,7 +9544,7 @@
           <a:noFill/>
         </p:spPr>
         <p:txBody>
-          <a:bodyPr wrap="square">
+          <a:bodyPr wrap="square" lIns="27432" rIns="27432" tIns="18288" bIns="18288">
             <a:spAutoFit/>
           </a:bodyPr>
           <a:lstStyle/>
@@ -9680,8 +9696,8 @@
         </p:nvSpPr>
         <p:spPr>
           <a:xfrm>
-            <a:off x="4590288" y="1581912"/>
-            <a:ext cx="3044952" cy="274320"/>
+            <a:off x="4590288" y="1563624"/>
+            <a:ext cx="3044952" cy="402336"/>
           </a:xfrm>
           <a:prstGeom prst="rect">
             <a:avLst/>
@@ -9689,13 +9705,13 @@
           <a:noFill/>
         </p:spPr>
         <p:txBody>
-          <a:bodyPr wrap="none">
+          <a:bodyPr wrap="square" lIns="27432" rIns="27432" tIns="18288" bIns="18288">
             <a:spAutoFit/>
           </a:bodyPr>
           <a:lstStyle/>
           <a:p>
             <a:pPr>
-              <a:defRPr sz="1600" b="1">
+              <a:defRPr sz="1200" b="1">
                 <a:solidFill>
                   <a:srgbClr val="0F172A"/>
                 </a:solidFill>
@@ -9716,8 +9732,8 @@
         </p:nvSpPr>
         <p:spPr>
           <a:xfrm>
-            <a:off x="4590288" y="1947672"/>
-            <a:ext cx="3044952" cy="2194560"/>
+            <a:off x="4590288" y="1984248"/>
+            <a:ext cx="3044952" cy="2176272"/>
           </a:xfrm>
           <a:prstGeom prst="rect">
             <a:avLst/>
@@ -9725,7 +9741,7 @@
           <a:noFill/>
         </p:spPr>
         <p:txBody>
-          <a:bodyPr wrap="square">
+          <a:bodyPr wrap="square" lIns="27432" rIns="27432" tIns="18288" bIns="18288">
             <a:spAutoFit/>
           </a:bodyPr>
           <a:lstStyle/>
@@ -9877,8 +9893,8 @@
         </p:nvSpPr>
         <p:spPr>
           <a:xfrm>
-            <a:off x="8293608" y="1581912"/>
-            <a:ext cx="3044952" cy="274320"/>
+            <a:off x="8293608" y="1563624"/>
+            <a:ext cx="3044952" cy="402336"/>
           </a:xfrm>
           <a:prstGeom prst="rect">
             <a:avLst/>
@@ -9886,13 +9902,13 @@
           <a:noFill/>
         </p:spPr>
         <p:txBody>
-          <a:bodyPr wrap="none">
+          <a:bodyPr wrap="square" lIns="27432" rIns="27432" tIns="18288" bIns="18288">
             <a:spAutoFit/>
           </a:bodyPr>
           <a:lstStyle/>
           <a:p>
             <a:pPr>
-              <a:defRPr sz="1600" b="1">
+              <a:defRPr sz="1200" b="1">
                 <a:solidFill>
                   <a:srgbClr val="0F172A"/>
                 </a:solidFill>
@@ -9913,8 +9929,8 @@
         </p:nvSpPr>
         <p:spPr>
           <a:xfrm>
-            <a:off x="8293608" y="1947672"/>
-            <a:ext cx="3044952" cy="2194560"/>
+            <a:off x="8293608" y="1984248"/>
+            <a:ext cx="3044952" cy="2176272"/>
           </a:xfrm>
           <a:prstGeom prst="rect">
             <a:avLst/>
@@ -9922,7 +9938,7 @@
           <a:noFill/>
         </p:spPr>
         <p:txBody>
-          <a:bodyPr wrap="square">
+          <a:bodyPr wrap="square" lIns="27432" rIns="27432" tIns="18288" bIns="18288">
             <a:spAutoFit/>
           </a:bodyPr>
           <a:lstStyle/>
@@ -9993,7 +10009,7 @@
           <a:noFill/>
         </p:spPr>
         <p:txBody>
-          <a:bodyPr wrap="none">
+          <a:bodyPr wrap="square" lIns="73152" rIns="73152" tIns="27432" bIns="27432">
             <a:spAutoFit/>
           </a:bodyPr>
           <a:lstStyle/>
@@ -10085,8 +10101,8 @@
         </p:nvSpPr>
         <p:spPr>
           <a:xfrm>
-            <a:off x="502920" y="292608"/>
-            <a:ext cx="7772400" cy="502920"/>
+            <a:off x="685800" y="292608"/>
+            <a:ext cx="8549640" cy="566928"/>
           </a:xfrm>
           <a:prstGeom prst="rect">
             <a:avLst/>
@@ -10094,13 +10110,13 @@
           <a:noFill/>
         </p:spPr>
         <p:txBody>
-          <a:bodyPr wrap="none">
+          <a:bodyPr wrap="square" lIns="54864" rIns="54864" tIns="18288" bIns="18288">
             <a:spAutoFit/>
           </a:bodyPr>
           <a:lstStyle/>
           <a:p>
             <a:pPr>
-              <a:defRPr sz="3000" b="1">
+              <a:defRPr sz="2900" b="1">
                 <a:solidFill>
                   <a:srgbClr val="0F172A"/>
                 </a:solidFill>
@@ -10266,8 +10282,8 @@
         </p:nvSpPr>
         <p:spPr>
           <a:xfrm>
-            <a:off x="932688" y="1581912"/>
-            <a:ext cx="1993392" cy="274320"/>
+            <a:off x="932688" y="1563624"/>
+            <a:ext cx="1993392" cy="402336"/>
           </a:xfrm>
           <a:prstGeom prst="rect">
             <a:avLst/>
@@ -10275,13 +10291,13 @@
           <a:noFill/>
         </p:spPr>
         <p:txBody>
-          <a:bodyPr wrap="none">
+          <a:bodyPr wrap="square" lIns="27432" rIns="27432" tIns="18288" bIns="18288">
             <a:spAutoFit/>
           </a:bodyPr>
           <a:lstStyle/>
           <a:p>
             <a:pPr>
-              <a:defRPr sz="1600" b="1">
+              <a:defRPr sz="1200" b="1">
                 <a:solidFill>
                   <a:srgbClr val="0F172A"/>
                 </a:solidFill>
@@ -10302,8 +10318,8 @@
         </p:nvSpPr>
         <p:spPr>
           <a:xfrm>
-            <a:off x="932688" y="1947672"/>
-            <a:ext cx="1993392" cy="457200"/>
+            <a:off x="932688" y="1984248"/>
+            <a:ext cx="1993392" cy="438912"/>
           </a:xfrm>
           <a:prstGeom prst="rect">
             <a:avLst/>
@@ -10311,7 +10327,7 @@
           <a:noFill/>
         </p:spPr>
         <p:txBody>
-          <a:bodyPr wrap="square">
+          <a:bodyPr wrap="square" lIns="27432" rIns="27432" tIns="18288" bIns="18288">
             <a:spAutoFit/>
           </a:bodyPr>
           <a:lstStyle/>
@@ -10431,8 +10447,8 @@
         </p:nvSpPr>
         <p:spPr>
           <a:xfrm>
-            <a:off x="3858768" y="1581912"/>
-            <a:ext cx="1993392" cy="274320"/>
+            <a:off x="3858768" y="1563624"/>
+            <a:ext cx="1993392" cy="310896"/>
           </a:xfrm>
           <a:prstGeom prst="rect">
             <a:avLst/>
@@ -10440,7 +10456,7 @@
           <a:noFill/>
         </p:spPr>
         <p:txBody>
-          <a:bodyPr wrap="none">
+          <a:bodyPr wrap="square" lIns="27432" rIns="27432" tIns="18288" bIns="18288">
             <a:spAutoFit/>
           </a:bodyPr>
           <a:lstStyle/>
@@ -10468,7 +10484,7 @@
         <p:spPr>
           <a:xfrm>
             <a:off x="3858768" y="1947672"/>
-            <a:ext cx="1993392" cy="457200"/>
+            <a:ext cx="1993392" cy="475488"/>
           </a:xfrm>
           <a:prstGeom prst="rect">
             <a:avLst/>
@@ -10476,7 +10492,7 @@
           <a:noFill/>
         </p:spPr>
         <p:txBody>
-          <a:bodyPr wrap="square">
+          <a:bodyPr wrap="square" lIns="27432" rIns="27432" tIns="18288" bIns="18288">
             <a:spAutoFit/>
           </a:bodyPr>
           <a:lstStyle/>
@@ -10612,8 +10628,8 @@
         </p:nvSpPr>
         <p:spPr>
           <a:xfrm>
-            <a:off x="6784848" y="1581912"/>
-            <a:ext cx="1993392" cy="274320"/>
+            <a:off x="6784848" y="1563624"/>
+            <a:ext cx="1993392" cy="402336"/>
           </a:xfrm>
           <a:prstGeom prst="rect">
             <a:avLst/>
@@ -10621,13 +10637,13 @@
           <a:noFill/>
         </p:spPr>
         <p:txBody>
-          <a:bodyPr wrap="none">
+          <a:bodyPr wrap="square" lIns="27432" rIns="27432" tIns="18288" bIns="18288">
             <a:spAutoFit/>
           </a:bodyPr>
           <a:lstStyle/>
           <a:p>
             <a:pPr>
-              <a:defRPr sz="1600" b="1">
+              <a:defRPr sz="1200" b="1">
                 <a:solidFill>
                   <a:srgbClr val="0F172A"/>
                 </a:solidFill>
@@ -10648,8 +10664,8 @@
         </p:nvSpPr>
         <p:spPr>
           <a:xfrm>
-            <a:off x="6784848" y="1947672"/>
-            <a:ext cx="1993392" cy="457200"/>
+            <a:off x="6784848" y="1984248"/>
+            <a:ext cx="1993392" cy="438912"/>
           </a:xfrm>
           <a:prstGeom prst="rect">
             <a:avLst/>
@@ -10657,7 +10673,7 @@
           <a:noFill/>
         </p:spPr>
         <p:txBody>
-          <a:bodyPr wrap="square">
+          <a:bodyPr wrap="square" lIns="27432" rIns="27432" tIns="18288" bIns="18288">
             <a:spAutoFit/>
           </a:bodyPr>
           <a:lstStyle/>
@@ -10777,8 +10793,8 @@
         </p:nvSpPr>
         <p:spPr>
           <a:xfrm>
-            <a:off x="9710928" y="1581912"/>
-            <a:ext cx="1627632" cy="274320"/>
+            <a:off x="9710928" y="1563624"/>
+            <a:ext cx="1627632" cy="310896"/>
           </a:xfrm>
           <a:prstGeom prst="rect">
             <a:avLst/>
@@ -10786,7 +10802,7 @@
           <a:noFill/>
         </p:spPr>
         <p:txBody>
-          <a:bodyPr wrap="none">
+          <a:bodyPr wrap="square" lIns="27432" rIns="27432" tIns="18288" bIns="18288">
             <a:spAutoFit/>
           </a:bodyPr>
           <a:lstStyle/>
@@ -10814,7 +10830,7 @@
         <p:spPr>
           <a:xfrm>
             <a:off x="9710928" y="1947672"/>
-            <a:ext cx="1627632" cy="457200"/>
+            <a:ext cx="1627632" cy="475488"/>
           </a:xfrm>
           <a:prstGeom prst="rect">
             <a:avLst/>
@@ -10822,7 +10838,7 @@
           <a:noFill/>
         </p:spPr>
         <p:txBody>
-          <a:bodyPr wrap="square">
+          <a:bodyPr wrap="square" lIns="27432" rIns="27432" tIns="18288" bIns="18288">
             <a:spAutoFit/>
           </a:bodyPr>
           <a:lstStyle/>
@@ -10966,7 +10982,7 @@
           <a:noFill/>
         </p:spPr>
         <p:txBody>
-          <a:bodyPr wrap="none">
+          <a:bodyPr wrap="square" lIns="73152" rIns="73152" tIns="27432" bIns="27432">
             <a:spAutoFit/>
           </a:bodyPr>
           <a:lstStyle/>
@@ -11058,8 +11074,8 @@
         </p:nvSpPr>
         <p:spPr>
           <a:xfrm>
-            <a:off x="502920" y="292608"/>
-            <a:ext cx="7772400" cy="502920"/>
+            <a:off x="685800" y="292608"/>
+            <a:ext cx="8549640" cy="566928"/>
           </a:xfrm>
           <a:prstGeom prst="rect">
             <a:avLst/>
@@ -11067,13 +11083,13 @@
           <a:noFill/>
         </p:spPr>
         <p:txBody>
-          <a:bodyPr wrap="none">
+          <a:bodyPr wrap="square" lIns="54864" rIns="54864" tIns="18288" bIns="18288">
             <a:spAutoFit/>
           </a:bodyPr>
           <a:lstStyle/>
           <a:p>
             <a:pPr>
-              <a:defRPr sz="3000" b="1">
+              <a:defRPr sz="2900" b="1">
                 <a:solidFill>
                   <a:srgbClr val="0F172A"/>
                 </a:solidFill>
@@ -11239,8 +11255,8 @@
         </p:nvSpPr>
         <p:spPr>
           <a:xfrm>
-            <a:off x="978408" y="1490472"/>
-            <a:ext cx="2816352" cy="274320"/>
+            <a:off x="978408" y="1472184"/>
+            <a:ext cx="2816352" cy="310896"/>
           </a:xfrm>
           <a:prstGeom prst="rect">
             <a:avLst/>
@@ -11248,7 +11264,7 @@
           <a:noFill/>
         </p:spPr>
         <p:txBody>
-          <a:bodyPr wrap="none">
+          <a:bodyPr wrap="square" lIns="27432" rIns="27432" tIns="18288" bIns="18288">
             <a:spAutoFit/>
           </a:bodyPr>
           <a:lstStyle/>
@@ -11276,7 +11292,7 @@
         <p:spPr>
           <a:xfrm>
             <a:off x="978408" y="1856231"/>
-            <a:ext cx="2816352" cy="777240"/>
+            <a:ext cx="2816352" cy="795528"/>
           </a:xfrm>
           <a:prstGeom prst="rect">
             <a:avLst/>
@@ -11284,7 +11300,7 @@
           <a:noFill/>
         </p:spPr>
         <p:txBody>
-          <a:bodyPr wrap="square">
+          <a:bodyPr wrap="square" lIns="27432" rIns="27432" tIns="18288" bIns="18288">
             <a:spAutoFit/>
           </a:bodyPr>
           <a:lstStyle/>
@@ -11420,8 +11436,8 @@
         </p:nvSpPr>
         <p:spPr>
           <a:xfrm>
-            <a:off x="4681728" y="1490472"/>
-            <a:ext cx="2816352" cy="274320"/>
+            <a:off x="4681728" y="1472184"/>
+            <a:ext cx="2816352" cy="310896"/>
           </a:xfrm>
           <a:prstGeom prst="rect">
             <a:avLst/>
@@ -11429,7 +11445,7 @@
           <a:noFill/>
         </p:spPr>
         <p:txBody>
-          <a:bodyPr wrap="none">
+          <a:bodyPr wrap="square" lIns="27432" rIns="27432" tIns="18288" bIns="18288">
             <a:spAutoFit/>
           </a:bodyPr>
           <a:lstStyle/>
@@ -11457,7 +11473,7 @@
         <p:spPr>
           <a:xfrm>
             <a:off x="4681728" y="1856231"/>
-            <a:ext cx="2816352" cy="777240"/>
+            <a:ext cx="2816352" cy="795528"/>
           </a:xfrm>
           <a:prstGeom prst="rect">
             <a:avLst/>
@@ -11465,7 +11481,7 @@
           <a:noFill/>
         </p:spPr>
         <p:txBody>
-          <a:bodyPr wrap="square">
+          <a:bodyPr wrap="square" lIns="27432" rIns="27432" tIns="18288" bIns="18288">
             <a:spAutoFit/>
           </a:bodyPr>
           <a:lstStyle/>
@@ -11601,8 +11617,8 @@
         </p:nvSpPr>
         <p:spPr>
           <a:xfrm>
-            <a:off x="8385048" y="1490472"/>
-            <a:ext cx="2816352" cy="274320"/>
+            <a:off x="8385048" y="1472184"/>
+            <a:ext cx="2816352" cy="310896"/>
           </a:xfrm>
           <a:prstGeom prst="rect">
             <a:avLst/>
@@ -11610,7 +11626,7 @@
           <a:noFill/>
         </p:spPr>
         <p:txBody>
-          <a:bodyPr wrap="none">
+          <a:bodyPr wrap="square" lIns="27432" rIns="27432" tIns="18288" bIns="18288">
             <a:spAutoFit/>
           </a:bodyPr>
           <a:lstStyle/>
@@ -11638,7 +11654,7 @@
         <p:spPr>
           <a:xfrm>
             <a:off x="8385048" y="1856231"/>
-            <a:ext cx="2816352" cy="777240"/>
+            <a:ext cx="2816352" cy="795528"/>
           </a:xfrm>
           <a:prstGeom prst="rect">
             <a:avLst/>
@@ -11646,7 +11662,7 @@
           <a:noFill/>
         </p:spPr>
         <p:txBody>
-          <a:bodyPr wrap="square">
+          <a:bodyPr wrap="square" lIns="27432" rIns="27432" tIns="18288" bIns="18288">
             <a:spAutoFit/>
           </a:bodyPr>
           <a:lstStyle/>
@@ -11701,7 +11717,7 @@
           <a:noFill/>
         </p:spPr>
         <p:txBody>
-          <a:bodyPr wrap="none">
+          <a:bodyPr wrap="square" lIns="73152" rIns="73152" tIns="27432" bIns="27432">
             <a:spAutoFit/>
           </a:bodyPr>
           <a:lstStyle/>
@@ -11793,8 +11809,8 @@
         </p:nvSpPr>
         <p:spPr>
           <a:xfrm>
-            <a:off x="502920" y="292608"/>
-            <a:ext cx="7772400" cy="502920"/>
+            <a:off x="685800" y="292608"/>
+            <a:ext cx="8549640" cy="566928"/>
           </a:xfrm>
           <a:prstGeom prst="rect">
             <a:avLst/>
@@ -11802,13 +11818,13 @@
           <a:noFill/>
         </p:spPr>
         <p:txBody>
-          <a:bodyPr wrap="none">
+          <a:bodyPr wrap="square" lIns="54864" rIns="54864" tIns="18288" bIns="18288">
             <a:spAutoFit/>
           </a:bodyPr>
           <a:lstStyle/>
           <a:p>
             <a:pPr>
-              <a:defRPr sz="3000" b="1">
+              <a:defRPr sz="2900" b="1">
                 <a:solidFill>
                   <a:srgbClr val="0F172A"/>
                 </a:solidFill>
@@ -11884,8 +11900,8 @@
         </p:nvSpPr>
         <p:spPr>
           <a:xfrm>
-            <a:off x="777240" y="1325880"/>
-            <a:ext cx="6766560" cy="4389120"/>
+            <a:off x="868680" y="1325880"/>
+            <a:ext cx="6217920" cy="4389120"/>
           </a:xfrm>
           <a:prstGeom prst="rect">
             <a:avLst/>
@@ -11893,7 +11909,7 @@
           <a:noFill/>
         </p:spPr>
         <p:txBody>
-          <a:bodyPr wrap="none">
+          <a:bodyPr wrap="square" lIns="73152" rIns="73152" tIns="27432" bIns="27432">
             <a:spAutoFit/>
           </a:bodyPr>
           <a:lstStyle/>

</xml_diff>